<commit_message>
docs: chem schema drift reconciled — chem_schema_migration_v3.sql + init_chem_db applies v1->v2->v3 (commit 313e495)
</commit_message>
<xml_diff>
--- a/presentation/UNanofabTools/flaskserver/slides/10-Database-Models.pptx
+++ b/presentation/UNanofabTools/flaskserver/slides/10-Database-Models.pptx
@@ -1393,7 +1393,7 @@
           <a:p>
             <a:r>
               <a:rPr lang="en-US" dirty="0"/>
-              <a:t>Two things a successor must know. First, the server auto-creates brand-new tables on startup, but it will not alter an existing table — that requires a 'migration,' which is a recorded, repeatable change script. Always use migrations so every copy of the database stays in step. Second, the live chemical-inventory database has drifted slightly ahead of the saved schema files (a few columns and a table were added directly over time). That's captured in the separate issues list with the exact fixes; it matters if anyone rebuilds the inventory database from scratch.</a:t>
+              <a:t>Two things a successor must know. First, the server auto-creates brand-new tables on startup, but it will not alter an existing table — that requires a 'migration,' which is a recorded, repeatable change script. Always use migrations so every copy of the database stays in step. Second, the chemical-inventory schema files used to lag behind the live database (a few columns and a table had been added directly over time); that drift was reconciled on 2026-06-29 by the v3 migration, and the provisioning script now applies v1 through v3 so a fresh build matches production. Keep it that way by writing a migration for any future live change.</a:t>
             </a:r>
             <a:endParaRPr lang="en-US" dirty="0"/>
           </a:p>
@@ -2989,7 +2989,7 @@
                 <a:ea typeface="Calibri" pitchFamily="34" charset="-122"/>
                 <a:cs typeface="Calibri" pitchFamily="34" charset="-120"/>
               </a:rPr>
-              <a:t>Evolve tables with migrations; mind the inventory's schema drift.</a:t>
+              <a:t>Evolve tables with migrations; the inventory's schema drift was reconciled (v3, 2026-06-29).</a:t>
             </a:r>
             <a:endParaRPr lang="en-US" sz="1500" dirty="0"/>
           </a:p>
@@ -5824,7 +5824,7 @@
                 <a:ea typeface="Calibri" pitchFamily="34" charset="-122"/>
                 <a:cs typeface="Calibri" pitchFamily="34" charset="-120"/>
               </a:rPr>
-              <a:t>The live inventory database has a few columns added over time that aren't yet in the saved schema files.</a:t>
+              <a:t>The inventory schema files were reconciled with the live database on 2026-06-29 (the v3 migration), so a fresh build now matches production.</a:t>
             </a:r>
             <a:endParaRPr lang="en-US" sz="1500" dirty="0"/>
           </a:p>

</xml_diff>